<commit_message>
Add MicrofluidicClassificationEngine.jl, interactive cytometry/3D workbench, Python reference verifier, and Ghosh/Jack visualization slides (for contributor review)
</commit_message>
<xml_diff>
--- a/presentations/Single_Cell_Flow_Cytometry_Model_Bridge_Exploratory.pptx
+++ b/presentations/Single_Cell_Flow_Cytometry_Model_Bridge_Exploratory.pptx
@@ -9,6 +9,7 @@
     <p:sldId id="257" r:id="rId9"/>
     <p:sldId id="258" r:id="rId10"/>
     <p:sldId id="259" r:id="rId11"/>
+    <p:sldId id="260" r:id="rId12"/>
   </p:sldIdLst>
   <p:sldSz cx="12191999" cy="6858000" type="screen4x3"/>
   <p:notesSz cx="6858000" cy="9144000"/>
@@ -731,6 +732,52 @@
           </p:nvPr>
         </p:nvSpPr>
         <p:spPr/>
+      </p:sp>
+    </p:spTree>
+  </p:cSld>
+  <p:clrMapOvr>
+    <a:masterClrMapping/>
+  </p:clrMapOvr>
+</p:notes>
+</file>
+
+<file path=ppt/notesSlides/notesSlide5.xml><?xml version="1.0" encoding="utf-8"?>
+<p:notes xmlns:a="http://schemas.openxmlformats.org/drawingml/2006/main" xmlns:p="http://schemas.openxmlformats.org/presentationml/2006/main" xmlns:r="http://schemas.openxmlformats.org/officeDocument/2006/relationships">
+  <p:cSld>
+    <p:spTree>
+      <p:nvGrpSpPr>
+        <p:cNvPr id="1" name=""/>
+        <p:cNvGrpSpPr/>
+        <p:nvPr/>
+      </p:nvGrpSpPr>
+      <p:grpSpPr>
+        <a:xfrm>
+          <a:off x="0" y="0"/>
+          <a:ext cx="0" cy="0"/>
+          <a:chOff x="0" y="0"/>
+          <a:chExt cx="0" cy="0"/>
+        </a:xfrm>
+      </p:grpSpPr>
+      <p:sp>
+        <p:nvSpPr>
+          <p:cNvPr id="3" name="Notes Placeholder 2"/>
+          <p:cNvSpPr>
+            <a:spLocks noGrp="1"/>
+          </p:cNvSpPr>
+          <p:nvPr>
+            <p:ph type="body" idx="3" sz="quarter"/>
+          </p:nvPr>
+        </p:nvSpPr>
+        <p:spPr/>
+        <p:txBody>
+          <a:bodyPr/>
+          <a:lstStyle/>
+          <a:p>
+            <a:r>
+              <a:t>Core-Multishell Reaction-Diffusion and Microfluidic Single-Cell Classification. Shells represent simulated concentration fields (:predicted), not observed physical layers.</a:t>
+            </a:r>
+          </a:p>
+        </p:txBody>
       </p:sp>
     </p:spTree>
   </p:cSld>
@@ -7604,6 +7651,56 @@
           </a:p>
         </p:txBody>
       </p:sp>
+    </p:spTree>
+  </p:cSld>
+  <p:clrMapOvr>
+    <a:masterClrMapping/>
+  </p:clrMapOvr>
+</p:sld>
+</file>
+
+<file path=ppt/slides/slide5.xml><?xml version="1.0" encoding="utf-8"?>
+<p:sld xmlns:a="http://schemas.openxmlformats.org/drawingml/2006/main" xmlns:p="http://schemas.openxmlformats.org/presentationml/2006/main" xmlns:r="http://schemas.openxmlformats.org/officeDocument/2006/relationships">
+  <p:cSld>
+    <p:bg>
+      <p:bgPr>
+        <a:solidFill>
+          <a:srgbClr val="F6F5F0"/>
+        </a:solidFill>
+        <a:effectLst/>
+      </p:bgPr>
+    </p:bg>
+    <p:spTree>
+      <p:nvGrpSpPr>
+        <p:cNvPr id="1" name=""/>
+        <p:cNvGrpSpPr/>
+        <p:nvPr/>
+      </p:nvGrpSpPr>
+      <p:grpSpPr/>
+      <p:pic>
+        <p:nvPicPr>
+          <p:cNvPr id="2" name="SlideRender" descr="High-resolution domain visualization slide"/>
+          <p:cNvPicPr>
+            <a:picLocks noChangeAspect="1"/>
+          </p:cNvPicPr>
+          <p:nvPr/>
+        </p:nvPicPr>
+        <p:blipFill>
+          <a:blip r:embed="rId3"/>
+          <a:stretch>
+            <a:fillRect/>
+          </a:stretch>
+        </p:blipFill>
+        <p:spPr>
+          <a:xfrm>
+            <a:off x="0" y="0"/>
+            <a:ext cx="12191999" cy="6858000"/>
+          </a:xfrm>
+          <a:prstGeom prst="rect">
+            <a:avLst/>
+          </a:prstGeom>
+        </p:spPr>
+      </p:pic>
     </p:spTree>
   </p:cSld>
   <p:clrMapOvr>

</xml_diff>